<commit_message>
initial commit: GoReportPilot MVP
</commit_message>
<xml_diff>
--- a/backend/templates/pptx/bold_geometric.pptx
+++ b/backend/templates/pptx/bold_geometric.pptx
@@ -2496,6 +2496,10 @@
           </a:solidFill>
           <a:ln/>
         </p:spPr>
+        <p:txBody>
+          <a:bodyPr/>
+          <a:p/>
+        </p:txBody>
       </p:sp>
       <p:sp>
         <p:nvSpPr>
@@ -2555,6 +2559,10 @@
           </a:solidFill>
           <a:ln/>
         </p:spPr>
+        <p:txBody>
+          <a:bodyPr/>
+          <a:p/>
+        </p:txBody>
       </p:sp>
       <p:sp>
         <p:nvSpPr>
@@ -2841,6 +2849,10 @@
           </a:solidFill>
           <a:ln/>
         </p:spPr>
+        <p:txBody>
+          <a:bodyPr/>
+          <a:p/>
+        </p:txBody>
       </p:sp>
       <p:sp>
         <p:nvSpPr>
@@ -2861,6 +2873,10 @@
           </a:solidFill>
           <a:ln/>
         </p:spPr>
+        <p:txBody>
+          <a:bodyPr/>
+          <a:p/>
+        </p:txBody>
       </p:sp>
       <p:sp>
         <p:nvSpPr>
@@ -2929,6 +2945,10 @@
             </a:outerShdw>
           </a:effectLst>
         </p:spPr>
+        <p:txBody>
+          <a:bodyPr/>
+          <a:p/>
+        </p:txBody>
       </p:sp>
       <p:sp>
         <p:nvSpPr>
@@ -3101,6 +3121,10 @@
           </a:solidFill>
           <a:ln/>
         </p:spPr>
+        <p:txBody>
+          <a:bodyPr/>
+          <a:p/>
+        </p:txBody>
       </p:sp>
       <p:sp>
         <p:nvSpPr>
@@ -3121,6 +3145,10 @@
           </a:solidFill>
           <a:ln/>
         </p:spPr>
+        <p:txBody>
+          <a:bodyPr/>
+          <a:p/>
+        </p:txBody>
       </p:sp>
       <p:sp>
         <p:nvSpPr>
@@ -3189,6 +3217,10 @@
             </a:outerShdw>
           </a:effectLst>
         </p:spPr>
+        <p:txBody>
+          <a:bodyPr/>
+          <a:p/>
+        </p:txBody>
       </p:sp>
       <p:sp>
         <p:nvSpPr>
@@ -3257,6 +3289,10 @@
             </a:outerShdw>
           </a:effectLst>
         </p:spPr>
+        <p:txBody>
+          <a:bodyPr/>
+          <a:p/>
+        </p:txBody>
       </p:sp>
       <p:sp>
         <p:nvSpPr>
@@ -3429,6 +3465,10 @@
           </a:solidFill>
           <a:ln/>
         </p:spPr>
+        <p:txBody>
+          <a:bodyPr/>
+          <a:p/>
+        </p:txBody>
       </p:sp>
       <p:sp>
         <p:nvSpPr>
@@ -3449,6 +3489,10 @@
           </a:solidFill>
           <a:ln/>
         </p:spPr>
+        <p:txBody>
+          <a:bodyPr/>
+          <a:p/>
+        </p:txBody>
       </p:sp>
       <p:sp>
         <p:nvSpPr>
@@ -3517,6 +3561,10 @@
             </a:outerShdw>
           </a:effectLst>
         </p:spPr>
+        <p:txBody>
+          <a:bodyPr/>
+          <a:p/>
+        </p:txBody>
       </p:sp>
       <p:sp>
         <p:nvSpPr>
@@ -3689,6 +3737,10 @@
           </a:solidFill>
           <a:ln/>
         </p:spPr>
+        <p:txBody>
+          <a:bodyPr/>
+          <a:p/>
+        </p:txBody>
       </p:sp>
       <p:sp>
         <p:nvSpPr>
@@ -3709,6 +3761,10 @@
           </a:solidFill>
           <a:ln/>
         </p:spPr>
+        <p:txBody>
+          <a:bodyPr/>
+          <a:p/>
+        </p:txBody>
       </p:sp>
       <p:sp>
         <p:nvSpPr>
@@ -3777,6 +3833,10 @@
             </a:outerShdw>
           </a:effectLst>
         </p:spPr>
+        <p:txBody>
+          <a:bodyPr/>
+          <a:p/>
+        </p:txBody>
       </p:sp>
       <p:sp>
         <p:nvSpPr>
@@ -3845,6 +3905,10 @@
             </a:outerShdw>
           </a:effectLst>
         </p:spPr>
+        <p:txBody>
+          <a:bodyPr/>
+          <a:p/>
+        </p:txBody>
       </p:sp>
       <p:sp>
         <p:nvSpPr>
@@ -4017,6 +4081,10 @@
           </a:solidFill>
           <a:ln/>
         </p:spPr>
+        <p:txBody>
+          <a:bodyPr/>
+          <a:p/>
+        </p:txBody>
       </p:sp>
       <p:sp>
         <p:nvSpPr>
@@ -4037,6 +4105,10 @@
           </a:solidFill>
           <a:ln/>
         </p:spPr>
+        <p:txBody>
+          <a:bodyPr/>
+          <a:p/>
+        </p:txBody>
       </p:sp>
       <p:sp>
         <p:nvSpPr>
@@ -4105,6 +4177,10 @@
             </a:outerShdw>
           </a:effectLst>
         </p:spPr>
+        <p:txBody>
+          <a:bodyPr/>
+          <a:p/>
+        </p:txBody>
       </p:sp>
       <p:sp>
         <p:nvSpPr>
@@ -4125,6 +4201,10 @@
           </a:solidFill>
           <a:ln/>
         </p:spPr>
+        <p:txBody>
+          <a:bodyPr/>
+          <a:p/>
+        </p:txBody>
       </p:sp>
       <p:sp>
         <p:nvSpPr>
@@ -4232,6 +4312,10 @@
             </a:outerShdw>
           </a:effectLst>
         </p:spPr>
+        <p:txBody>
+          <a:bodyPr/>
+          <a:p/>
+        </p:txBody>
       </p:sp>
       <p:sp>
         <p:nvSpPr>
@@ -4252,6 +4336,10 @@
           </a:solidFill>
           <a:ln/>
         </p:spPr>
+        <p:txBody>
+          <a:bodyPr/>
+          <a:p/>
+        </p:txBody>
       </p:sp>
       <p:sp>
         <p:nvSpPr>
@@ -4359,6 +4447,10 @@
             </a:outerShdw>
           </a:effectLst>
         </p:spPr>
+        <p:txBody>
+          <a:bodyPr/>
+          <a:p/>
+        </p:txBody>
       </p:sp>
       <p:sp>
         <p:nvSpPr>
@@ -4379,6 +4471,10 @@
           </a:solidFill>
           <a:ln/>
         </p:spPr>
+        <p:txBody>
+          <a:bodyPr/>
+          <a:p/>
+        </p:txBody>
       </p:sp>
       <p:sp>
         <p:nvSpPr>
@@ -4486,6 +4582,10 @@
             </a:outerShdw>
           </a:effectLst>
         </p:spPr>
+        <p:txBody>
+          <a:bodyPr/>
+          <a:p/>
+        </p:txBody>
       </p:sp>
       <p:sp>
         <p:nvSpPr>
@@ -4506,6 +4606,10 @@
           </a:solidFill>
           <a:ln/>
         </p:spPr>
+        <p:txBody>
+          <a:bodyPr/>
+          <a:p/>
+        </p:txBody>
       </p:sp>
       <p:sp>
         <p:nvSpPr>
@@ -4613,6 +4717,10 @@
             </a:outerShdw>
           </a:effectLst>
         </p:spPr>
+        <p:txBody>
+          <a:bodyPr/>
+          <a:p/>
+        </p:txBody>
       </p:sp>
       <p:sp>
         <p:nvSpPr>
@@ -4633,6 +4741,10 @@
           </a:solidFill>
           <a:ln/>
         </p:spPr>
+        <p:txBody>
+          <a:bodyPr/>
+          <a:p/>
+        </p:txBody>
       </p:sp>
       <p:sp>
         <p:nvSpPr>
@@ -4740,6 +4852,10 @@
             </a:outerShdw>
           </a:effectLst>
         </p:spPr>
+        <p:txBody>
+          <a:bodyPr/>
+          <a:p/>
+        </p:txBody>
       </p:sp>
       <p:sp>
         <p:nvSpPr>
@@ -4760,6 +4876,10 @@
           </a:solidFill>
           <a:ln/>
         </p:spPr>
+        <p:txBody>
+          <a:bodyPr/>
+          <a:p/>
+        </p:txBody>
       </p:sp>
       <p:sp>
         <p:nvSpPr>
@@ -4847,8 +4967,8 @@
         </p:nvSpPr>
         <p:spPr>
           <a:xfrm>
-            <a:off x="731520" y="3749040"/>
-            <a:ext cx="10698480" cy="2286000"/>
+            <a:off x="731520" y="3913632"/>
+            <a:ext cx="10698480" cy="2459736"/>
           </a:xfrm>
           <a:prstGeom prst="roundRect">
             <a:avLst>
@@ -4867,6 +4987,10 @@
             </a:outerShdw>
           </a:effectLst>
         </p:spPr>
+        <p:txBody>
+          <a:bodyPr/>
+          <a:p/>
+        </p:txBody>
       </p:sp>
       <p:sp>
         <p:nvSpPr>
@@ -4876,8 +5000,8 @@
         </p:nvSpPr>
         <p:spPr>
           <a:xfrm>
-            <a:off x="731520" y="3749040"/>
-            <a:ext cx="10698480" cy="2286000"/>
+            <a:off x="731520" y="3913632"/>
+            <a:ext cx="10698480" cy="2459736"/>
           </a:xfrm>
           <a:prstGeom prst="rect">
             <a:avLst/>
@@ -6104,6 +6228,10 @@
           </a:solidFill>
           <a:ln/>
         </p:spPr>
+        <p:txBody>
+          <a:bodyPr/>
+          <a:p/>
+        </p:txBody>
       </p:sp>
       <p:sp>
         <p:nvSpPr>
@@ -6124,6 +6252,10 @@
           </a:solidFill>
           <a:ln/>
         </p:spPr>
+        <p:txBody>
+          <a:bodyPr/>
+          <a:p/>
+        </p:txBody>
       </p:sp>
       <p:sp>
         <p:nvSpPr>
@@ -6296,6 +6428,10 @@
           </a:solidFill>
           <a:ln/>
         </p:spPr>
+        <p:txBody>
+          <a:bodyPr/>
+          <a:p/>
+        </p:txBody>
       </p:sp>
       <p:sp>
         <p:nvSpPr>
@@ -6316,6 +6452,10 @@
           </a:solidFill>
           <a:ln/>
         </p:spPr>
+        <p:txBody>
+          <a:bodyPr/>
+          <a:p/>
+        </p:txBody>
       </p:sp>
       <p:sp>
         <p:nvSpPr>
@@ -6382,6 +6522,10 @@
             </a:outerShdw>
           </a:effectLst>
         </p:spPr>
+        <p:txBody>
+          <a:bodyPr/>
+          <a:p/>
+        </p:txBody>
       </p:sp>
       <p:sp>
         <p:nvSpPr>
@@ -6402,6 +6546,10 @@
           </a:solidFill>
           <a:ln/>
         </p:spPr>
+        <p:txBody>
+          <a:bodyPr/>
+          <a:p/>
+        </p:txBody>
       </p:sp>
       <p:sp>
         <p:nvSpPr>
@@ -6546,6 +6694,10 @@
             </a:outerShdw>
           </a:effectLst>
         </p:spPr>
+        <p:txBody>
+          <a:bodyPr/>
+          <a:p/>
+        </p:txBody>
       </p:sp>
       <p:sp>
         <p:nvSpPr>
@@ -6566,6 +6718,10 @@
           </a:solidFill>
           <a:ln/>
         </p:spPr>
+        <p:txBody>
+          <a:bodyPr/>
+          <a:p/>
+        </p:txBody>
       </p:sp>
       <p:sp>
         <p:nvSpPr>
@@ -6710,6 +6866,10 @@
             </a:outerShdw>
           </a:effectLst>
         </p:spPr>
+        <p:txBody>
+          <a:bodyPr/>
+          <a:p/>
+        </p:txBody>
       </p:sp>
       <p:sp>
         <p:nvSpPr>
@@ -6730,6 +6890,10 @@
           </a:solidFill>
           <a:ln/>
         </p:spPr>
+        <p:txBody>
+          <a:bodyPr/>
+          <a:p/>
+        </p:txBody>
       </p:sp>
       <p:sp>
         <p:nvSpPr>
@@ -6874,6 +7038,10 @@
             </a:outerShdw>
           </a:effectLst>
         </p:spPr>
+        <p:txBody>
+          <a:bodyPr/>
+          <a:p/>
+        </p:txBody>
       </p:sp>
       <p:sp>
         <p:nvSpPr>
@@ -6894,6 +7062,10 @@
           </a:solidFill>
           <a:ln/>
         </p:spPr>
+        <p:txBody>
+          <a:bodyPr/>
+          <a:p/>
+        </p:txBody>
       </p:sp>
       <p:sp>
         <p:nvSpPr>
@@ -7038,6 +7210,10 @@
             </a:outerShdw>
           </a:effectLst>
         </p:spPr>
+        <p:txBody>
+          <a:bodyPr/>
+          <a:p/>
+        </p:txBody>
       </p:sp>
       <p:sp>
         <p:nvSpPr>
@@ -7058,6 +7234,10 @@
           </a:solidFill>
           <a:ln/>
         </p:spPr>
+        <p:txBody>
+          <a:bodyPr/>
+          <a:p/>
+        </p:txBody>
       </p:sp>
       <p:sp>
         <p:nvSpPr>
@@ -7202,6 +7382,10 @@
             </a:outerShdw>
           </a:effectLst>
         </p:spPr>
+        <p:txBody>
+          <a:bodyPr/>
+          <a:p/>
+        </p:txBody>
       </p:sp>
       <p:sp>
         <p:nvSpPr>
@@ -7222,6 +7406,10 @@
           </a:solidFill>
           <a:ln/>
         </p:spPr>
+        <p:txBody>
+          <a:bodyPr/>
+          <a:p/>
+        </p:txBody>
       </p:sp>
       <p:sp>
         <p:nvSpPr>
@@ -7430,6 +7618,10 @@
           </a:solidFill>
           <a:ln/>
         </p:spPr>
+        <p:txBody>
+          <a:bodyPr/>
+          <a:p/>
+        </p:txBody>
       </p:sp>
       <p:sp>
         <p:nvSpPr>
@@ -7450,6 +7642,10 @@
           </a:solidFill>
           <a:ln/>
         </p:spPr>
+        <p:txBody>
+          <a:bodyPr/>
+          <a:p/>
+        </p:txBody>
       </p:sp>
       <p:sp>
         <p:nvSpPr>
@@ -7518,6 +7714,10 @@
             </a:outerShdw>
           </a:effectLst>
         </p:spPr>
+        <p:txBody>
+          <a:bodyPr/>
+          <a:p/>
+        </p:txBody>
       </p:sp>
       <p:sp>
         <p:nvSpPr>
@@ -7586,6 +7786,10 @@
             </a:outerShdw>
           </a:effectLst>
         </p:spPr>
+        <p:txBody>
+          <a:bodyPr/>
+          <a:p/>
+        </p:txBody>
       </p:sp>
       <p:sp>
         <p:nvSpPr>
@@ -7758,6 +7962,10 @@
           </a:solidFill>
           <a:ln/>
         </p:spPr>
+        <p:txBody>
+          <a:bodyPr/>
+          <a:p/>
+        </p:txBody>
       </p:sp>
       <p:sp>
         <p:nvSpPr>
@@ -7778,6 +7986,10 @@
           </a:solidFill>
           <a:ln/>
         </p:spPr>
+        <p:txBody>
+          <a:bodyPr/>
+          <a:p/>
+        </p:txBody>
       </p:sp>
       <p:sp>
         <p:nvSpPr>
@@ -7846,6 +8058,10 @@
             </a:outerShdw>
           </a:effectLst>
         </p:spPr>
+        <p:txBody>
+          <a:bodyPr/>
+          <a:p/>
+        </p:txBody>
       </p:sp>
       <p:sp>
         <p:nvSpPr>
@@ -7914,6 +8130,10 @@
             </a:outerShdw>
           </a:effectLst>
         </p:spPr>
+        <p:txBody>
+          <a:bodyPr/>
+          <a:p/>
+        </p:txBody>
       </p:sp>
       <p:sp>
         <p:nvSpPr>
@@ -8086,6 +8306,10 @@
           </a:solidFill>
           <a:ln/>
         </p:spPr>
+        <p:txBody>
+          <a:bodyPr/>
+          <a:p/>
+        </p:txBody>
       </p:sp>
       <p:sp>
         <p:nvSpPr>
@@ -8106,6 +8330,10 @@
           </a:solidFill>
           <a:ln/>
         </p:spPr>
+        <p:txBody>
+          <a:bodyPr/>
+          <a:p/>
+        </p:txBody>
       </p:sp>
       <p:sp>
         <p:nvSpPr>
@@ -8174,6 +8402,10 @@
             </a:outerShdw>
           </a:effectLst>
         </p:spPr>
+        <p:txBody>
+          <a:bodyPr/>
+          <a:p/>
+        </p:txBody>
       </p:sp>
       <p:sp>
         <p:nvSpPr>
@@ -8242,6 +8474,10 @@
             </a:outerShdw>
           </a:effectLst>
         </p:spPr>
+        <p:txBody>
+          <a:bodyPr/>
+          <a:p/>
+        </p:txBody>
       </p:sp>
       <p:sp>
         <p:nvSpPr>
@@ -8414,6 +8650,10 @@
           </a:solidFill>
           <a:ln/>
         </p:spPr>
+        <p:txBody>
+          <a:bodyPr/>
+          <a:p/>
+        </p:txBody>
       </p:sp>
       <p:sp>
         <p:nvSpPr>
@@ -8434,6 +8674,10 @@
           </a:solidFill>
           <a:ln/>
         </p:spPr>
+        <p:txBody>
+          <a:bodyPr/>
+          <a:p/>
+        </p:txBody>
       </p:sp>
       <p:sp>
         <p:nvSpPr>
@@ -8502,6 +8746,10 @@
             </a:outerShdw>
           </a:effectLst>
         </p:spPr>
+        <p:txBody>
+          <a:bodyPr/>
+          <a:p/>
+        </p:txBody>
       </p:sp>
       <p:sp>
         <p:nvSpPr>
@@ -8674,6 +8922,10 @@
           </a:solidFill>
           <a:ln/>
         </p:spPr>
+        <p:txBody>
+          <a:bodyPr/>
+          <a:p/>
+        </p:txBody>
       </p:sp>
       <p:sp>
         <p:nvSpPr>
@@ -8694,6 +8946,10 @@
           </a:solidFill>
           <a:ln/>
         </p:spPr>
+        <p:txBody>
+          <a:bodyPr/>
+          <a:p/>
+        </p:txBody>
       </p:sp>
       <p:sp>
         <p:nvSpPr>
@@ -8762,6 +9018,10 @@
             </a:outerShdw>
           </a:effectLst>
         </p:spPr>
+        <p:txBody>
+          <a:bodyPr/>
+          <a:p/>
+        </p:txBody>
       </p:sp>
       <p:sp>
         <p:nvSpPr>
@@ -8830,6 +9090,10 @@
             </a:outerShdw>
           </a:effectLst>
         </p:spPr>
+        <p:txBody>
+          <a:bodyPr/>
+          <a:p/>
+        </p:txBody>
       </p:sp>
       <p:sp>
         <p:nvSpPr>
@@ -9002,6 +9266,10 @@
           </a:solidFill>
           <a:ln/>
         </p:spPr>
+        <p:txBody>
+          <a:bodyPr/>
+          <a:p/>
+        </p:txBody>
       </p:sp>
       <p:sp>
         <p:nvSpPr>
@@ -9022,6 +9290,10 @@
           </a:solidFill>
           <a:ln/>
         </p:spPr>
+        <p:txBody>
+          <a:bodyPr/>
+          <a:p/>
+        </p:txBody>
       </p:sp>
       <p:sp>
         <p:nvSpPr>
@@ -9090,6 +9362,10 @@
             </a:outerShdw>
           </a:effectLst>
         </p:spPr>
+        <p:txBody>
+          <a:bodyPr/>
+          <a:p/>
+        </p:txBody>
       </p:sp>
       <p:sp>
         <p:nvSpPr>
@@ -9158,6 +9434,10 @@
             </a:outerShdw>
           </a:effectLst>
         </p:spPr>
+        <p:txBody>
+          <a:bodyPr/>
+          <a:p/>
+        </p:txBody>
       </p:sp>
       <p:sp>
         <p:nvSpPr>

</xml_diff>

<commit_message>
fix: agency name on cover slide + add website engagement narrative
Bug 1 — Agency name:
- Add .strip() to agency_name fallback chain in both reports.py and
  report_generator.py to handle whitespace-only values robustly
- Fallback chain: branding → client_info → "Your Agency"

Bug 2 — Website Engagement narrative:
- Add engagement_analysis section to AI narrative engine with instruction
  for device breakdown, top pages, and user behavior insights
- Add {{engagement_narrative}} placeholder to all 6 PPTX template scripts
  (slide 4, was sharing {{website_narrative}} which got cleared)
- Regenerate all 6 PPTX templates
- Map engagement slide in _NARRATIVE_SLIDES for formatted text injection
- Add {{engagement_narrative}} to replacements dict
- AI now requests engagement_analysis when GA4 device/pages data exists

Co-Authored-By: Claude Opus 4.6 (1M context) <noreply@anthropic.com>
</commit_message>
<xml_diff>
--- a/backend/templates/pptx/bold_geometric.pptx
+++ b/backend/templates/pptx/bold_geometric.pptx
@@ -2496,10 +2496,6 @@
           </a:solidFill>
           <a:ln/>
         </p:spPr>
-        <p:txBody>
-          <a:bodyPr/>
-          <a:p/>
-        </p:txBody>
       </p:sp>
       <p:sp>
         <p:nvSpPr>
@@ -2559,10 +2555,6 @@
           </a:solidFill>
           <a:ln/>
         </p:spPr>
-        <p:txBody>
-          <a:bodyPr/>
-          <a:p/>
-        </p:txBody>
       </p:sp>
       <p:sp>
         <p:nvSpPr>
@@ -2849,10 +2841,6 @@
           </a:solidFill>
           <a:ln/>
         </p:spPr>
-        <p:txBody>
-          <a:bodyPr/>
-          <a:p/>
-        </p:txBody>
       </p:sp>
       <p:sp>
         <p:nvSpPr>
@@ -2873,10 +2861,6 @@
           </a:solidFill>
           <a:ln/>
         </p:spPr>
-        <p:txBody>
-          <a:bodyPr/>
-          <a:p/>
-        </p:txBody>
       </p:sp>
       <p:sp>
         <p:nvSpPr>
@@ -2945,10 +2929,6 @@
             </a:outerShdw>
           </a:effectLst>
         </p:spPr>
-        <p:txBody>
-          <a:bodyPr/>
-          <a:p/>
-        </p:txBody>
       </p:sp>
       <p:sp>
         <p:nvSpPr>
@@ -3121,10 +3101,6 @@
           </a:solidFill>
           <a:ln/>
         </p:spPr>
-        <p:txBody>
-          <a:bodyPr/>
-          <a:p/>
-        </p:txBody>
       </p:sp>
       <p:sp>
         <p:nvSpPr>
@@ -3145,10 +3121,6 @@
           </a:solidFill>
           <a:ln/>
         </p:spPr>
-        <p:txBody>
-          <a:bodyPr/>
-          <a:p/>
-        </p:txBody>
       </p:sp>
       <p:sp>
         <p:nvSpPr>
@@ -3217,10 +3189,6 @@
             </a:outerShdw>
           </a:effectLst>
         </p:spPr>
-        <p:txBody>
-          <a:bodyPr/>
-          <a:p/>
-        </p:txBody>
       </p:sp>
       <p:sp>
         <p:nvSpPr>
@@ -3289,10 +3257,6 @@
             </a:outerShdw>
           </a:effectLst>
         </p:spPr>
-        <p:txBody>
-          <a:bodyPr/>
-          <a:p/>
-        </p:txBody>
       </p:sp>
       <p:sp>
         <p:nvSpPr>
@@ -3465,10 +3429,6 @@
           </a:solidFill>
           <a:ln/>
         </p:spPr>
-        <p:txBody>
-          <a:bodyPr/>
-          <a:p/>
-        </p:txBody>
       </p:sp>
       <p:sp>
         <p:nvSpPr>
@@ -3489,10 +3449,6 @@
           </a:solidFill>
           <a:ln/>
         </p:spPr>
-        <p:txBody>
-          <a:bodyPr/>
-          <a:p/>
-        </p:txBody>
       </p:sp>
       <p:sp>
         <p:nvSpPr>
@@ -3561,10 +3517,6 @@
             </a:outerShdw>
           </a:effectLst>
         </p:spPr>
-        <p:txBody>
-          <a:bodyPr/>
-          <a:p/>
-        </p:txBody>
       </p:sp>
       <p:sp>
         <p:nvSpPr>
@@ -3737,10 +3689,6 @@
           </a:solidFill>
           <a:ln/>
         </p:spPr>
-        <p:txBody>
-          <a:bodyPr/>
-          <a:p/>
-        </p:txBody>
       </p:sp>
       <p:sp>
         <p:nvSpPr>
@@ -3761,10 +3709,6 @@
           </a:solidFill>
           <a:ln/>
         </p:spPr>
-        <p:txBody>
-          <a:bodyPr/>
-          <a:p/>
-        </p:txBody>
       </p:sp>
       <p:sp>
         <p:nvSpPr>
@@ -3833,10 +3777,6 @@
             </a:outerShdw>
           </a:effectLst>
         </p:spPr>
-        <p:txBody>
-          <a:bodyPr/>
-          <a:p/>
-        </p:txBody>
       </p:sp>
       <p:sp>
         <p:nvSpPr>
@@ -3905,10 +3845,6 @@
             </a:outerShdw>
           </a:effectLst>
         </p:spPr>
-        <p:txBody>
-          <a:bodyPr/>
-          <a:p/>
-        </p:txBody>
       </p:sp>
       <p:sp>
         <p:nvSpPr>
@@ -4081,10 +4017,6 @@
           </a:solidFill>
           <a:ln/>
         </p:spPr>
-        <p:txBody>
-          <a:bodyPr/>
-          <a:p/>
-        </p:txBody>
       </p:sp>
       <p:sp>
         <p:nvSpPr>
@@ -4105,10 +4037,6 @@
           </a:solidFill>
           <a:ln/>
         </p:spPr>
-        <p:txBody>
-          <a:bodyPr/>
-          <a:p/>
-        </p:txBody>
       </p:sp>
       <p:sp>
         <p:nvSpPr>
@@ -4177,10 +4105,6 @@
             </a:outerShdw>
           </a:effectLst>
         </p:spPr>
-        <p:txBody>
-          <a:bodyPr/>
-          <a:p/>
-        </p:txBody>
       </p:sp>
       <p:sp>
         <p:nvSpPr>
@@ -4201,10 +4125,6 @@
           </a:solidFill>
           <a:ln/>
         </p:spPr>
-        <p:txBody>
-          <a:bodyPr/>
-          <a:p/>
-        </p:txBody>
       </p:sp>
       <p:sp>
         <p:nvSpPr>
@@ -4312,10 +4232,6 @@
             </a:outerShdw>
           </a:effectLst>
         </p:spPr>
-        <p:txBody>
-          <a:bodyPr/>
-          <a:p/>
-        </p:txBody>
       </p:sp>
       <p:sp>
         <p:nvSpPr>
@@ -4336,10 +4252,6 @@
           </a:solidFill>
           <a:ln/>
         </p:spPr>
-        <p:txBody>
-          <a:bodyPr/>
-          <a:p/>
-        </p:txBody>
       </p:sp>
       <p:sp>
         <p:nvSpPr>
@@ -4447,10 +4359,6 @@
             </a:outerShdw>
           </a:effectLst>
         </p:spPr>
-        <p:txBody>
-          <a:bodyPr/>
-          <a:p/>
-        </p:txBody>
       </p:sp>
       <p:sp>
         <p:nvSpPr>
@@ -4471,10 +4379,6 @@
           </a:solidFill>
           <a:ln/>
         </p:spPr>
-        <p:txBody>
-          <a:bodyPr/>
-          <a:p/>
-        </p:txBody>
       </p:sp>
       <p:sp>
         <p:nvSpPr>
@@ -4582,10 +4486,6 @@
             </a:outerShdw>
           </a:effectLst>
         </p:spPr>
-        <p:txBody>
-          <a:bodyPr/>
-          <a:p/>
-        </p:txBody>
       </p:sp>
       <p:sp>
         <p:nvSpPr>
@@ -4606,10 +4506,6 @@
           </a:solidFill>
           <a:ln/>
         </p:spPr>
-        <p:txBody>
-          <a:bodyPr/>
-          <a:p/>
-        </p:txBody>
       </p:sp>
       <p:sp>
         <p:nvSpPr>
@@ -4717,10 +4613,6 @@
             </a:outerShdw>
           </a:effectLst>
         </p:spPr>
-        <p:txBody>
-          <a:bodyPr/>
-          <a:p/>
-        </p:txBody>
       </p:sp>
       <p:sp>
         <p:nvSpPr>
@@ -4741,10 +4633,6 @@
           </a:solidFill>
           <a:ln/>
         </p:spPr>
-        <p:txBody>
-          <a:bodyPr/>
-          <a:p/>
-        </p:txBody>
       </p:sp>
       <p:sp>
         <p:nvSpPr>
@@ -4852,10 +4740,6 @@
             </a:outerShdw>
           </a:effectLst>
         </p:spPr>
-        <p:txBody>
-          <a:bodyPr/>
-          <a:p/>
-        </p:txBody>
       </p:sp>
       <p:sp>
         <p:nvSpPr>
@@ -4876,10 +4760,6 @@
           </a:solidFill>
           <a:ln/>
         </p:spPr>
-        <p:txBody>
-          <a:bodyPr/>
-          <a:p/>
-        </p:txBody>
       </p:sp>
       <p:sp>
         <p:nvSpPr>
@@ -4967,8 +4847,8 @@
         </p:nvSpPr>
         <p:spPr>
           <a:xfrm>
-            <a:off x="731520" y="3913632"/>
-            <a:ext cx="10698480" cy="2459736"/>
+            <a:off x="731520" y="3749040"/>
+            <a:ext cx="10698480" cy="2286000"/>
           </a:xfrm>
           <a:prstGeom prst="roundRect">
             <a:avLst>
@@ -4987,10 +4867,6 @@
             </a:outerShdw>
           </a:effectLst>
         </p:spPr>
-        <p:txBody>
-          <a:bodyPr/>
-          <a:p/>
-        </p:txBody>
       </p:sp>
       <p:sp>
         <p:nvSpPr>
@@ -5000,8 +4876,8 @@
         </p:nvSpPr>
         <p:spPr>
           <a:xfrm>
-            <a:off x="731520" y="3913632"/>
-            <a:ext cx="10698480" cy="2459736"/>
+            <a:off x="731520" y="3749040"/>
+            <a:ext cx="10698480" cy="2286000"/>
           </a:xfrm>
           <a:prstGeom prst="rect">
             <a:avLst/>
@@ -6228,10 +6104,6 @@
           </a:solidFill>
           <a:ln/>
         </p:spPr>
-        <p:txBody>
-          <a:bodyPr/>
-          <a:p/>
-        </p:txBody>
       </p:sp>
       <p:sp>
         <p:nvSpPr>
@@ -6252,10 +6124,6 @@
           </a:solidFill>
           <a:ln/>
         </p:spPr>
-        <p:txBody>
-          <a:bodyPr/>
-          <a:p/>
-        </p:txBody>
       </p:sp>
       <p:sp>
         <p:nvSpPr>
@@ -6428,10 +6296,6 @@
           </a:solidFill>
           <a:ln/>
         </p:spPr>
-        <p:txBody>
-          <a:bodyPr/>
-          <a:p/>
-        </p:txBody>
       </p:sp>
       <p:sp>
         <p:nvSpPr>
@@ -6452,10 +6316,6 @@
           </a:solidFill>
           <a:ln/>
         </p:spPr>
-        <p:txBody>
-          <a:bodyPr/>
-          <a:p/>
-        </p:txBody>
       </p:sp>
       <p:sp>
         <p:nvSpPr>
@@ -6522,10 +6382,6 @@
             </a:outerShdw>
           </a:effectLst>
         </p:spPr>
-        <p:txBody>
-          <a:bodyPr/>
-          <a:p/>
-        </p:txBody>
       </p:sp>
       <p:sp>
         <p:nvSpPr>
@@ -6546,10 +6402,6 @@
           </a:solidFill>
           <a:ln/>
         </p:spPr>
-        <p:txBody>
-          <a:bodyPr/>
-          <a:p/>
-        </p:txBody>
       </p:sp>
       <p:sp>
         <p:nvSpPr>
@@ -6694,10 +6546,6 @@
             </a:outerShdw>
           </a:effectLst>
         </p:spPr>
-        <p:txBody>
-          <a:bodyPr/>
-          <a:p/>
-        </p:txBody>
       </p:sp>
       <p:sp>
         <p:nvSpPr>
@@ -6718,10 +6566,6 @@
           </a:solidFill>
           <a:ln/>
         </p:spPr>
-        <p:txBody>
-          <a:bodyPr/>
-          <a:p/>
-        </p:txBody>
       </p:sp>
       <p:sp>
         <p:nvSpPr>
@@ -6866,10 +6710,6 @@
             </a:outerShdw>
           </a:effectLst>
         </p:spPr>
-        <p:txBody>
-          <a:bodyPr/>
-          <a:p/>
-        </p:txBody>
       </p:sp>
       <p:sp>
         <p:nvSpPr>
@@ -6890,10 +6730,6 @@
           </a:solidFill>
           <a:ln/>
         </p:spPr>
-        <p:txBody>
-          <a:bodyPr/>
-          <a:p/>
-        </p:txBody>
       </p:sp>
       <p:sp>
         <p:nvSpPr>
@@ -7038,10 +6874,6 @@
             </a:outerShdw>
           </a:effectLst>
         </p:spPr>
-        <p:txBody>
-          <a:bodyPr/>
-          <a:p/>
-        </p:txBody>
       </p:sp>
       <p:sp>
         <p:nvSpPr>
@@ -7062,10 +6894,6 @@
           </a:solidFill>
           <a:ln/>
         </p:spPr>
-        <p:txBody>
-          <a:bodyPr/>
-          <a:p/>
-        </p:txBody>
       </p:sp>
       <p:sp>
         <p:nvSpPr>
@@ -7210,10 +7038,6 @@
             </a:outerShdw>
           </a:effectLst>
         </p:spPr>
-        <p:txBody>
-          <a:bodyPr/>
-          <a:p/>
-        </p:txBody>
       </p:sp>
       <p:sp>
         <p:nvSpPr>
@@ -7234,10 +7058,6 @@
           </a:solidFill>
           <a:ln/>
         </p:spPr>
-        <p:txBody>
-          <a:bodyPr/>
-          <a:p/>
-        </p:txBody>
       </p:sp>
       <p:sp>
         <p:nvSpPr>
@@ -7382,10 +7202,6 @@
             </a:outerShdw>
           </a:effectLst>
         </p:spPr>
-        <p:txBody>
-          <a:bodyPr/>
-          <a:p/>
-        </p:txBody>
       </p:sp>
       <p:sp>
         <p:nvSpPr>
@@ -7406,10 +7222,6 @@
           </a:solidFill>
           <a:ln/>
         </p:spPr>
-        <p:txBody>
-          <a:bodyPr/>
-          <a:p/>
-        </p:txBody>
       </p:sp>
       <p:sp>
         <p:nvSpPr>
@@ -7618,10 +7430,6 @@
           </a:solidFill>
           <a:ln/>
         </p:spPr>
-        <p:txBody>
-          <a:bodyPr/>
-          <a:p/>
-        </p:txBody>
       </p:sp>
       <p:sp>
         <p:nvSpPr>
@@ -7642,10 +7450,6 @@
           </a:solidFill>
           <a:ln/>
         </p:spPr>
-        <p:txBody>
-          <a:bodyPr/>
-          <a:p/>
-        </p:txBody>
       </p:sp>
       <p:sp>
         <p:nvSpPr>
@@ -7714,10 +7518,6 @@
             </a:outerShdw>
           </a:effectLst>
         </p:spPr>
-        <p:txBody>
-          <a:bodyPr/>
-          <a:p/>
-        </p:txBody>
       </p:sp>
       <p:sp>
         <p:nvSpPr>
@@ -7786,10 +7586,6 @@
             </a:outerShdw>
           </a:effectLst>
         </p:spPr>
-        <p:txBody>
-          <a:bodyPr/>
-          <a:p/>
-        </p:txBody>
       </p:sp>
       <p:sp>
         <p:nvSpPr>
@@ -7962,10 +7758,6 @@
           </a:solidFill>
           <a:ln/>
         </p:spPr>
-        <p:txBody>
-          <a:bodyPr/>
-          <a:p/>
-        </p:txBody>
       </p:sp>
       <p:sp>
         <p:nvSpPr>
@@ -7986,10 +7778,6 @@
           </a:solidFill>
           <a:ln/>
         </p:spPr>
-        <p:txBody>
-          <a:bodyPr/>
-          <a:p/>
-        </p:txBody>
       </p:sp>
       <p:sp>
         <p:nvSpPr>
@@ -8058,10 +7846,6 @@
             </a:outerShdw>
           </a:effectLst>
         </p:spPr>
-        <p:txBody>
-          <a:bodyPr/>
-          <a:p/>
-        </p:txBody>
       </p:sp>
       <p:sp>
         <p:nvSpPr>
@@ -8130,10 +7914,6 @@
             </a:outerShdw>
           </a:effectLst>
         </p:spPr>
-        <p:txBody>
-          <a:bodyPr/>
-          <a:p/>
-        </p:txBody>
       </p:sp>
       <p:sp>
         <p:nvSpPr>
@@ -8210,7 +7990,7 @@
                 <a:ea typeface="Calibri" pitchFamily="34" charset="-122"/>
                 <a:cs typeface="Calibri" pitchFamily="34" charset="-120"/>
               </a:rPr>
-              <a:t>{{website_narrative}}</a:t>
+              <a:t>{{engagement_narrative}}</a:t>
             </a:r>
             <a:endParaRPr lang="en-US" sz="1200" dirty="0"/>
           </a:p>
@@ -8306,10 +8086,6 @@
           </a:solidFill>
           <a:ln/>
         </p:spPr>
-        <p:txBody>
-          <a:bodyPr/>
-          <a:p/>
-        </p:txBody>
       </p:sp>
       <p:sp>
         <p:nvSpPr>
@@ -8330,10 +8106,6 @@
           </a:solidFill>
           <a:ln/>
         </p:spPr>
-        <p:txBody>
-          <a:bodyPr/>
-          <a:p/>
-        </p:txBody>
       </p:sp>
       <p:sp>
         <p:nvSpPr>
@@ -8402,10 +8174,6 @@
             </a:outerShdw>
           </a:effectLst>
         </p:spPr>
-        <p:txBody>
-          <a:bodyPr/>
-          <a:p/>
-        </p:txBody>
       </p:sp>
       <p:sp>
         <p:nvSpPr>
@@ -8474,10 +8242,6 @@
             </a:outerShdw>
           </a:effectLst>
         </p:spPr>
-        <p:txBody>
-          <a:bodyPr/>
-          <a:p/>
-        </p:txBody>
       </p:sp>
       <p:sp>
         <p:nvSpPr>
@@ -8650,10 +8414,6 @@
           </a:solidFill>
           <a:ln/>
         </p:spPr>
-        <p:txBody>
-          <a:bodyPr/>
-          <a:p/>
-        </p:txBody>
       </p:sp>
       <p:sp>
         <p:nvSpPr>
@@ -8674,10 +8434,6 @@
           </a:solidFill>
           <a:ln/>
         </p:spPr>
-        <p:txBody>
-          <a:bodyPr/>
-          <a:p/>
-        </p:txBody>
       </p:sp>
       <p:sp>
         <p:nvSpPr>
@@ -8746,10 +8502,6 @@
             </a:outerShdw>
           </a:effectLst>
         </p:spPr>
-        <p:txBody>
-          <a:bodyPr/>
-          <a:p/>
-        </p:txBody>
       </p:sp>
       <p:sp>
         <p:nvSpPr>
@@ -8922,10 +8674,6 @@
           </a:solidFill>
           <a:ln/>
         </p:spPr>
-        <p:txBody>
-          <a:bodyPr/>
-          <a:p/>
-        </p:txBody>
       </p:sp>
       <p:sp>
         <p:nvSpPr>
@@ -8946,10 +8694,6 @@
           </a:solidFill>
           <a:ln/>
         </p:spPr>
-        <p:txBody>
-          <a:bodyPr/>
-          <a:p/>
-        </p:txBody>
       </p:sp>
       <p:sp>
         <p:nvSpPr>
@@ -9018,10 +8762,6 @@
             </a:outerShdw>
           </a:effectLst>
         </p:spPr>
-        <p:txBody>
-          <a:bodyPr/>
-          <a:p/>
-        </p:txBody>
       </p:sp>
       <p:sp>
         <p:nvSpPr>
@@ -9090,10 +8830,6 @@
             </a:outerShdw>
           </a:effectLst>
         </p:spPr>
-        <p:txBody>
-          <a:bodyPr/>
-          <a:p/>
-        </p:txBody>
       </p:sp>
       <p:sp>
         <p:nvSpPr>
@@ -9266,10 +9002,6 @@
           </a:solidFill>
           <a:ln/>
         </p:spPr>
-        <p:txBody>
-          <a:bodyPr/>
-          <a:p/>
-        </p:txBody>
       </p:sp>
       <p:sp>
         <p:nvSpPr>
@@ -9290,10 +9022,6 @@
           </a:solidFill>
           <a:ln/>
         </p:spPr>
-        <p:txBody>
-          <a:bodyPr/>
-          <a:p/>
-        </p:txBody>
       </p:sp>
       <p:sp>
         <p:nvSpPr>
@@ -9362,10 +9090,6 @@
             </a:outerShdw>
           </a:effectLst>
         </p:spPr>
-        <p:txBody>
-          <a:bodyPr/>
-          <a:p/>
-        </p:txBody>
       </p:sp>
       <p:sp>
         <p:nvSpPr>
@@ -9434,10 +9158,6 @@
             </a:outerShdw>
           </a:effectLst>
         </p:spPr>
-        <p:txBody>
-          <a:bodyPr/>
-          <a:p/>
-        </p:txBody>
       </p:sp>
       <p:sp>
         <p:nvSpPr>

</xml_diff>